<commit_message>
feat: har slaydga joylangan PNG diagrammalar qo'shildi (sof Python grafikasi)
- generate_presentation.py: mini-grafika dvijok (Canvas + 5x7 bitmap shrift +
  PNG koder) va 10 ta diagramma (USB anatomiyasi, NAND matritsa, floating-gate
  kesimi, SLC/MLC Vth grafiklari, yozish/o'qish/o'chirish sxemasi, rasm->bayt
  ->katakcha zanjiri, 3D NAND + sig'im grafigi, bannerlar)
- Har bir slaydda endi haqiqiy joylangan rasm (<p:pic> + ppt/media/*.png)
- slideMaster/slideLayout XML da yetishmagan yopuvchi teglar tuzatildi
- verify_presentation.py: joylangan rasmlarni ham tekshiradi
- README.md yangilandi
</commit_message>
<xml_diff>
--- a/Fleshkalar_USB_malumot_saqlashi.pptx
+++ b/Fleshkalar_USB_malumot_saqlashi.pptx
@@ -276,9 +276,33 @@
           </a:p>
         </p:txBody>
       </p:sp>
-      <p:sp>
-        <p:nvSpPr>
-          <p:cNvPr id="6" name="maintitle"/>
+      <p:pic>
+        <p:nvPicPr>
+          <p:cNvPr id="6" name="banner"/>
+          <p:cNvPicPr>
+            <a:picLocks noChangeAspect="1"/>
+          </p:cNvPicPr>
+          <p:nvPr/>
+        </p:nvPicPr>
+        <p:blipFill>
+          <a:blip r:embed="rId2"/>
+          <a:stretch>
+            <a:fillRect/>
+          </a:stretch>
+        </p:blipFill>
+        <p:spPr>
+          <a:xfrm>
+            <a:off x="686000" y="1500000"/>
+            <a:ext cx="10820000" cy="1315000"/>
+          </a:xfrm>
+          <a:prstGeom prst="rect">
+            <a:avLst/>
+          </a:prstGeom>
+        </p:spPr>
+      </p:pic>
+      <p:sp>
+        <p:nvSpPr>
+          <p:cNvPr id="7" name="maintitle"/>
           <p:cNvSpPr>
             <a:spLocks noGrp="1"/>
           </p:cNvSpPr>
@@ -286,8 +310,8 @@
         </p:nvSpPr>
         <p:spPr>
           <a:xfrm>
-            <a:off x="686000" y="2300000"/>
-            <a:ext cx="10820000" cy="2000000"/>
+            <a:off x="686000" y="2950000"/>
+            <a:ext cx="10820000" cy="1600000"/>
           </a:xfrm>
           <a:prstGeom prst="rect">
             <a:avLst/>
@@ -345,7 +369,7 @@
       </p:sp>
       <p:sp>
         <p:nvSpPr>
-          <p:cNvPr id="7" name="presenter"/>
+          <p:cNvPr id="8" name="presenter"/>
           <p:cNvSpPr>
             <a:spLocks noGrp="1"/>
           </p:cNvSpPr>
@@ -353,8 +377,8 @@
         </p:nvSpPr>
         <p:spPr>
           <a:xfrm>
-            <a:off x="686000" y="4700000"/>
-            <a:ext cx="10820000" cy="900000"/>
+            <a:off x="686000" y="4680000"/>
+            <a:ext cx="10820000" cy="800000"/>
           </a:xfrm>
           <a:prstGeom prst="rect">
             <a:avLst/>
@@ -412,7 +436,7 @@
       </p:sp>
       <p:sp>
         <p:nvSpPr>
-          <p:cNvPr id="8" name="url_caption"/>
+          <p:cNvPr id="9" name="url_caption"/>
           <p:cNvSpPr>
             <a:spLocks noGrp="1"/>
           </p:cNvSpPr>
@@ -593,9 +617,33 @@
           <a:p/>
         </p:txBody>
       </p:sp>
-      <p:sp>
-        <p:nvSpPr>
-          <p:cNvPr id="5" name="thanks"/>
+      <p:pic>
+        <p:nvPicPr>
+          <p:cNvPr id="5" name="banner3"/>
+          <p:cNvPicPr>
+            <a:picLocks noChangeAspect="1"/>
+          </p:cNvPicPr>
+          <p:nvPr/>
+        </p:nvPicPr>
+        <p:blipFill>
+          <a:blip r:embed="rId2"/>
+          <a:stretch>
+            <a:fillRect/>
+          </a:stretch>
+        </p:blipFill>
+        <p:spPr>
+          <a:xfrm>
+            <a:off x="686000" y="880000"/>
+            <a:ext cx="10820000" cy="1315000"/>
+          </a:xfrm>
+          <a:prstGeom prst="rect">
+            <a:avLst/>
+          </a:prstGeom>
+        </p:spPr>
+      </p:pic>
+      <p:sp>
+        <p:nvSpPr>
+          <p:cNvPr id="6" name="thanks"/>
           <p:cNvSpPr>
             <a:spLocks noGrp="1"/>
           </p:cNvSpPr>
@@ -603,8 +651,8 @@
         </p:nvSpPr>
         <p:spPr>
           <a:xfrm>
-            <a:off x="686000" y="2300000"/>
-            <a:ext cx="10820000" cy="2400000"/>
+            <a:off x="686000" y="2500000"/>
+            <a:ext cx="10820000" cy="2300000"/>
           </a:xfrm>
           <a:prstGeom prst="rect">
             <a:avLst/>
@@ -683,7 +731,7 @@
       </p:sp>
       <p:sp>
         <p:nvSpPr>
-          <p:cNvPr id="6" name="url_caption"/>
+          <p:cNvPr id="7" name="url_caption"/>
           <p:cNvSpPr>
             <a:spLocks noGrp="1"/>
           </p:cNvSpPr>
@@ -1005,9 +1053,33 @@
           </a:p>
         </p:txBody>
       </p:sp>
-      <p:sp>
-        <p:nvSpPr>
-          <p:cNvPr id="5" name="url_caption"/>
+      <p:pic>
+        <p:nvPicPr>
+          <p:cNvPr id="5" name="banner2"/>
+          <p:cNvPicPr>
+            <a:picLocks noChangeAspect="1"/>
+          </p:cNvPicPr>
+          <p:nvPr/>
+        </p:nvPicPr>
+        <p:blipFill>
+          <a:blip r:embed="rId2"/>
+          <a:stretch>
+            <a:fillRect/>
+          </a:stretch>
+        </p:blipFill>
+        <p:spPr>
+          <a:xfrm>
+            <a:off x="686000" y="4860000"/>
+            <a:ext cx="10820000" cy="1052000"/>
+          </a:xfrm>
+          <a:prstGeom prst="rect">
+            <a:avLst/>
+          </a:prstGeom>
+        </p:spPr>
+      </p:pic>
+      <p:sp>
+        <p:nvSpPr>
+          <p:cNvPr id="6" name="url_caption"/>
           <p:cNvSpPr>
             <a:spLocks noGrp="1"/>
           </p:cNvSpPr>
@@ -1212,7 +1284,7 @@
         <p:spPr>
           <a:xfrm>
             <a:off x="686000" y="1500000"/>
-            <a:ext cx="10820000" cy="3400000"/>
+            <a:ext cx="5571280" cy="3900000"/>
           </a:xfrm>
           <a:prstGeom prst="rect">
             <a:avLst/>
@@ -1236,7 +1308,7 @@
               <a:buChar char="•"/>
             </a:pPr>
             <a:r>
-              <a:rPr lang="uz-UZ" sz="1800" b="1" i="0" dirty="0">
+              <a:rPr lang="uz-UZ" sz="1700" b="1" i="0" dirty="0">
                 <a:solidFill>
                   <a:srgbClr val="27E0C8"/>
                 </a:solidFill>
@@ -1246,7 +1318,7 @@
               <a:t>Qattiq jism xotirasi (Solid-State). </a:t>
             </a:r>
             <a:r>
-              <a:rPr lang="uz-UZ" sz="1600" b="0" i="0" dirty="0">
+              <a:rPr lang="uz-UZ" sz="1500" b="0" i="0" dirty="0">
                 <a:solidFill>
                   <a:srgbClr val="EAF2FF"/>
                 </a:solidFill>
@@ -1268,7 +1340,7 @@
               <a:buChar char="•"/>
             </a:pPr>
             <a:r>
-              <a:rPr lang="uz-UZ" sz="1800" b="1" i="0" dirty="0">
+              <a:rPr lang="uz-UZ" sz="1700" b="1" i="0" dirty="0">
                 <a:solidFill>
                   <a:srgbClr val="27E0C8"/>
                 </a:solidFill>
@@ -1278,7 +1350,7 @@
               <a:t>Harakatlanuvchi qismlar yo'q. </a:t>
             </a:r>
             <a:r>
-              <a:rPr lang="uz-UZ" sz="1600" b="0" i="0" dirty="0">
+              <a:rPr lang="uz-UZ" sz="1500" b="0" i="0" dirty="0">
                 <a:solidFill>
                   <a:srgbClr val="EAF2FF"/>
                 </a:solidFill>
@@ -1300,7 +1372,7 @@
               <a:buChar char="•"/>
             </a:pPr>
             <a:r>
-              <a:rPr lang="uz-UZ" sz="1800" b="1" i="0" dirty="0">
+              <a:rPr lang="uz-UZ" sz="1700" b="1" i="0" dirty="0">
                 <a:solidFill>
                   <a:srgbClr val="27E0C8"/>
                 </a:solidFill>
@@ -1310,7 +1382,7 @@
               <a:t>NAND tuzilmasi. </a:t>
             </a:r>
             <a:r>
-              <a:rPr lang="uz-UZ" sz="1600" b="0" i="0" dirty="0">
+              <a:rPr lang="uz-UZ" sz="1500" b="0" i="0" dirty="0">
                 <a:solidFill>
                   <a:srgbClr val="EAF2FF"/>
                 </a:solidFill>
@@ -1332,7 +1404,7 @@
               <a:buChar char="•"/>
             </a:pPr>
             <a:r>
-              <a:rPr lang="uz-UZ" sz="1800" b="1" i="0" dirty="0">
+              <a:rPr lang="uz-UZ" sz="1700" b="1" i="0" dirty="0">
                 <a:solidFill>
                   <a:srgbClr val="27E0C8"/>
                 </a:solidFill>
@@ -1342,7 +1414,7 @@
               <a:t>Energiyasiz saqlash. </a:t>
             </a:r>
             <a:r>
-              <a:rPr lang="uz-UZ" sz="1600" b="0" i="0" dirty="0">
+              <a:rPr lang="uz-UZ" sz="1500" b="0" i="0" dirty="0">
                 <a:solidFill>
                   <a:srgbClr val="EAF2FF"/>
                 </a:solidFill>
@@ -1354,9 +1426,33 @@
           </a:p>
         </p:txBody>
       </p:sp>
-      <p:sp>
-        <p:nvSpPr>
-          <p:cNvPr id="5" name="url_caption"/>
+      <p:pic>
+        <p:nvPicPr>
+          <p:cNvPr id="5" name="diagram"/>
+          <p:cNvPicPr>
+            <a:picLocks noChangeAspect="1"/>
+          </p:cNvPicPr>
+          <p:nvPr/>
+        </p:nvPicPr>
+        <p:blipFill>
+          <a:blip r:embed="rId2"/>
+          <a:stretch>
+            <a:fillRect/>
+          </a:stretch>
+        </p:blipFill>
+        <p:spPr>
+          <a:xfrm>
+            <a:off x="6507280" y="1550000"/>
+            <a:ext cx="4998720" cy="3767328"/>
+          </a:xfrm>
+          <a:prstGeom prst="rect">
+            <a:avLst/>
+          </a:prstGeom>
+        </p:spPr>
+      </p:pic>
+      <p:sp>
+        <p:nvSpPr>
+          <p:cNvPr id="6" name="url_caption"/>
           <p:cNvSpPr>
             <a:spLocks noGrp="1"/>
           </p:cNvSpPr>
@@ -1561,7 +1657,7 @@
         <p:spPr>
           <a:xfrm>
             <a:off x="686000" y="1500000"/>
-            <a:ext cx="10820000" cy="3400000"/>
+            <a:ext cx="5571280" cy="3900000"/>
           </a:xfrm>
           <a:prstGeom prst="rect">
             <a:avLst/>
@@ -1585,7 +1681,7 @@
               <a:buChar char="•"/>
             </a:pPr>
             <a:r>
-              <a:rPr lang="uz-UZ" sz="1800" b="1" i="0" dirty="0">
+              <a:rPr lang="uz-UZ" sz="1700" b="1" i="0" dirty="0">
                 <a:solidFill>
                   <a:srgbClr val="27E0C8"/>
                 </a:solidFill>
@@ -1595,7 +1691,7 @@
               <a:t>Xotira katakchasi (cell). </a:t>
             </a:r>
             <a:r>
-              <a:rPr lang="uz-UZ" sz="1600" b="0" i="0" dirty="0">
+              <a:rPr lang="uz-UZ" sz="1500" b="0" i="0" dirty="0">
                 <a:solidFill>
                   <a:srgbClr val="EAF2FF"/>
                 </a:solidFill>
@@ -1617,7 +1713,7 @@
               <a:buChar char="•"/>
             </a:pPr>
             <a:r>
-              <a:rPr lang="uz-UZ" sz="1800" b="1" i="0" dirty="0">
+              <a:rPr lang="uz-UZ" sz="1700" b="1" i="0" dirty="0">
                 <a:solidFill>
                   <a:srgbClr val="27E0C8"/>
                 </a:solidFill>
@@ -1627,7 +1723,7 @@
               <a:t>Qatorlar va ustunlar. </a:t>
             </a:r>
             <a:r>
-              <a:rPr lang="uz-UZ" sz="1600" b="0" i="0" dirty="0">
+              <a:rPr lang="uz-UZ" sz="1500" b="0" i="0" dirty="0">
                 <a:solidFill>
                   <a:srgbClr val="EAF2FF"/>
                 </a:solidFill>
@@ -1649,7 +1745,7 @@
               <a:buChar char="•"/>
             </a:pPr>
             <a:r>
-              <a:rPr lang="uz-UZ" sz="1800" b="1" i="0" dirty="0">
+              <a:rPr lang="uz-UZ" sz="1700" b="1" i="0" dirty="0">
                 <a:solidFill>
                   <a:srgbClr val="27E0C8"/>
                 </a:solidFill>
@@ -1659,7 +1755,7 @@
               <a:t>Zichlik va sig'im. </a:t>
             </a:r>
             <a:r>
-              <a:rPr lang="uz-UZ" sz="1600" b="0" i="0" dirty="0">
+              <a:rPr lang="uz-UZ" sz="1500" b="0" i="0" dirty="0">
                 <a:solidFill>
                   <a:srgbClr val="EAF2FF"/>
                 </a:solidFill>
@@ -1681,7 +1777,7 @@
               <a:buChar char="•"/>
             </a:pPr>
             <a:r>
-              <a:rPr lang="uz-UZ" sz="1800" b="1" i="0" dirty="0">
+              <a:rPr lang="uz-UZ" sz="1700" b="1" i="0" dirty="0">
                 <a:solidFill>
                   <a:srgbClr val="27E0C8"/>
                 </a:solidFill>
@@ -1691,7 +1787,7 @@
               <a:t>Ishonchlilik. </a:t>
             </a:r>
             <a:r>
-              <a:rPr lang="uz-UZ" sz="1600" b="0" i="0" dirty="0">
+              <a:rPr lang="uz-UZ" sz="1500" b="0" i="0" dirty="0">
                 <a:solidFill>
                   <a:srgbClr val="EAF2FF"/>
                 </a:solidFill>
@@ -1703,9 +1799,33 @@
           </a:p>
         </p:txBody>
       </p:sp>
-      <p:sp>
-        <p:nvSpPr>
-          <p:cNvPr id="5" name="url_caption"/>
+      <p:pic>
+        <p:nvPicPr>
+          <p:cNvPr id="5" name="diagram"/>
+          <p:cNvPicPr>
+            <a:picLocks noChangeAspect="1"/>
+          </p:cNvPicPr>
+          <p:nvPr/>
+        </p:nvPicPr>
+        <p:blipFill>
+          <a:blip r:embed="rId2"/>
+          <a:stretch>
+            <a:fillRect/>
+          </a:stretch>
+        </p:blipFill>
+        <p:spPr>
+          <a:xfrm>
+            <a:off x="6507280" y="1550000"/>
+            <a:ext cx="4998720" cy="3767328"/>
+          </a:xfrm>
+          <a:prstGeom prst="rect">
+            <a:avLst/>
+          </a:prstGeom>
+        </p:spPr>
+      </p:pic>
+      <p:sp>
+        <p:nvSpPr>
+          <p:cNvPr id="6" name="url_caption"/>
           <p:cNvSpPr>
             <a:spLocks noGrp="1"/>
           </p:cNvSpPr>
@@ -1910,7 +2030,7 @@
         <p:spPr>
           <a:xfrm>
             <a:off x="686000" y="1500000"/>
-            <a:ext cx="10820000" cy="3400000"/>
+            <a:ext cx="5571280" cy="3900000"/>
           </a:xfrm>
           <a:prstGeom prst="rect">
             <a:avLst/>
@@ -1934,7 +2054,7 @@
               <a:buChar char="•"/>
             </a:pPr>
             <a:r>
-              <a:rPr lang="uz-UZ" sz="1800" b="1" i="0" dirty="0">
+              <a:rPr lang="uz-UZ" sz="1700" b="1" i="0" dirty="0">
                 <a:solidFill>
                   <a:srgbClr val="27E0C8"/>
                 </a:solidFill>
@@ -1944,7 +2064,7 @@
               <a:t>Suzuvchi zulfin. </a:t>
             </a:r>
             <a:r>
-              <a:rPr lang="uz-UZ" sz="1600" b="0" i="0" dirty="0">
+              <a:rPr lang="uz-UZ" sz="1500" b="0" i="0" dirty="0">
                 <a:solidFill>
                   <a:srgbClr val="EAF2FF"/>
                 </a:solidFill>
@@ -1966,7 +2086,7 @@
               <a:buChar char="•"/>
             </a:pPr>
             <a:r>
-              <a:rPr lang="uz-UZ" sz="1800" b="1" i="0" dirty="0">
+              <a:rPr lang="uz-UZ" sz="1700" b="1" i="0" dirty="0">
                 <a:solidFill>
                   <a:srgbClr val="27E0C8"/>
                 </a:solidFill>
@@ -1976,7 +2096,7 @@
               <a:t>Elektronlarni qamab qo'yish. </a:t>
             </a:r>
             <a:r>
-              <a:rPr lang="uz-UZ" sz="1600" b="0" i="0" dirty="0">
+              <a:rPr lang="uz-UZ" sz="1500" b="0" i="0" dirty="0">
                 <a:solidFill>
                   <a:srgbClr val="EAF2FF"/>
                 </a:solidFill>
@@ -1998,7 +2118,7 @@
               <a:buChar char="•"/>
             </a:pPr>
             <a:r>
-              <a:rPr lang="uz-UZ" sz="1800" b="1" i="0" dirty="0">
+              <a:rPr lang="uz-UZ" sz="1700" b="1" i="0" dirty="0">
                 <a:solidFill>
                   <a:srgbClr val="27E0C8"/>
                 </a:solidFill>
@@ -2008,7 +2128,7 @@
               <a:t>Doimiy saqlash fizikasi. </a:t>
             </a:r>
             <a:r>
-              <a:rPr lang="uz-UZ" sz="1600" b="0" i="0" dirty="0">
+              <a:rPr lang="uz-UZ" sz="1500" b="0" i="0" dirty="0">
                 <a:solidFill>
                   <a:srgbClr val="EAF2FF"/>
                 </a:solidFill>
@@ -2020,9 +2140,33 @@
           </a:p>
         </p:txBody>
       </p:sp>
-      <p:sp>
-        <p:nvSpPr>
-          <p:cNvPr id="5" name="url_caption"/>
+      <p:pic>
+        <p:nvPicPr>
+          <p:cNvPr id="5" name="diagram"/>
+          <p:cNvPicPr>
+            <a:picLocks noChangeAspect="1"/>
+          </p:cNvPicPr>
+          <p:nvPr/>
+        </p:nvPicPr>
+        <p:blipFill>
+          <a:blip r:embed="rId2"/>
+          <a:stretch>
+            <a:fillRect/>
+          </a:stretch>
+        </p:blipFill>
+        <p:spPr>
+          <a:xfrm>
+            <a:off x="6507280" y="1550000"/>
+            <a:ext cx="4998720" cy="3767328"/>
+          </a:xfrm>
+          <a:prstGeom prst="rect">
+            <a:avLst/>
+          </a:prstGeom>
+        </p:spPr>
+      </p:pic>
+      <p:sp>
+        <p:nvSpPr>
+          <p:cNvPr id="6" name="url_caption"/>
           <p:cNvSpPr>
             <a:spLocks noGrp="1"/>
           </p:cNvSpPr>
@@ -2227,7 +2371,7 @@
         <p:spPr>
           <a:xfrm>
             <a:off x="686000" y="1500000"/>
-            <a:ext cx="10820000" cy="3400000"/>
+            <a:ext cx="5571280" cy="3900000"/>
           </a:xfrm>
           <a:prstGeom prst="rect">
             <a:avLst/>
@@ -2251,7 +2395,7 @@
               <a:buChar char="•"/>
             </a:pPr>
             <a:r>
-              <a:rPr lang="uz-UZ" sz="1800" b="1" i="0" dirty="0">
+              <a:rPr lang="uz-UZ" sz="1700" b="1" i="0" dirty="0">
                 <a:solidFill>
                   <a:srgbClr val="27E0C8"/>
                 </a:solidFill>
@@ -2261,7 +2405,7 @@
               <a:t>Zaryad miqdori — holat. </a:t>
             </a:r>
             <a:r>
-              <a:rPr lang="uz-UZ" sz="1600" b="0" i="0" dirty="0">
+              <a:rPr lang="uz-UZ" sz="1500" b="0" i="0" dirty="0">
                 <a:solidFill>
                   <a:srgbClr val="EAF2FF"/>
                 </a:solidFill>
@@ -2283,7 +2427,7 @@
               <a:buChar char="•"/>
             </a:pPr>
             <a:r>
-              <a:rPr lang="uz-UZ" sz="1800" b="1" i="0" dirty="0">
+              <a:rPr lang="uz-UZ" sz="1700" b="1" i="0" dirty="0">
                 <a:solidFill>
                   <a:srgbClr val="27E0C8"/>
                 </a:solidFill>
@@ -2293,7 +2437,7 @@
               <a:t>Chegaraviy kuchlanish. </a:t>
             </a:r>
             <a:r>
-              <a:rPr lang="uz-UZ" sz="1600" b="0" i="0" dirty="0">
+              <a:rPr lang="uz-UZ" sz="1500" b="0" i="0" dirty="0">
                 <a:solidFill>
                   <a:srgbClr val="EAF2FF"/>
                 </a:solidFill>
@@ -2315,7 +2459,7 @@
               <a:buChar char="•"/>
             </a:pPr>
             <a:r>
-              <a:rPr lang="uz-UZ" sz="1800" b="1" i="0" dirty="0">
+              <a:rPr lang="uz-UZ" sz="1700" b="1" i="0" dirty="0">
                 <a:solidFill>
                   <a:srgbClr val="27E0C8"/>
                 </a:solidFill>
@@ -2325,7 +2469,7 @@
               <a:t>Ko'p bitli katakchalar. </a:t>
             </a:r>
             <a:r>
-              <a:rPr lang="uz-UZ" sz="1600" b="0" i="0" dirty="0">
+              <a:rPr lang="uz-UZ" sz="1500" b="0" i="0" dirty="0">
                 <a:solidFill>
                   <a:srgbClr val="EAF2FF"/>
                 </a:solidFill>
@@ -2347,7 +2491,7 @@
               <a:buChar char="•"/>
             </a:pPr>
             <a:r>
-              <a:rPr lang="uz-UZ" sz="1800" b="1" i="0" dirty="0">
+              <a:rPr lang="uz-UZ" sz="1700" b="1" i="0" dirty="0">
                 <a:solidFill>
                   <a:srgbClr val="27E0C8"/>
                 </a:solidFill>
@@ -2357,7 +2501,7 @@
               <a:t>Barqarorlik. </a:t>
             </a:r>
             <a:r>
-              <a:rPr lang="uz-UZ" sz="1600" b="0" i="0" dirty="0">
+              <a:rPr lang="uz-UZ" sz="1500" b="0" i="0" dirty="0">
                 <a:solidFill>
                   <a:srgbClr val="EAF2FF"/>
                 </a:solidFill>
@@ -2369,9 +2513,33 @@
           </a:p>
         </p:txBody>
       </p:sp>
-      <p:sp>
-        <p:nvSpPr>
-          <p:cNvPr id="5" name="url_caption"/>
+      <p:pic>
+        <p:nvPicPr>
+          <p:cNvPr id="5" name="diagram"/>
+          <p:cNvPicPr>
+            <a:picLocks noChangeAspect="1"/>
+          </p:cNvPicPr>
+          <p:nvPr/>
+        </p:nvPicPr>
+        <p:blipFill>
+          <a:blip r:embed="rId2"/>
+          <a:stretch>
+            <a:fillRect/>
+          </a:stretch>
+        </p:blipFill>
+        <p:spPr>
+          <a:xfrm>
+            <a:off x="6507280" y="1550000"/>
+            <a:ext cx="4998720" cy="3767328"/>
+          </a:xfrm>
+          <a:prstGeom prst="rect">
+            <a:avLst/>
+          </a:prstGeom>
+        </p:spPr>
+      </p:pic>
+      <p:sp>
+        <p:nvSpPr>
+          <p:cNvPr id="6" name="url_caption"/>
           <p:cNvSpPr>
             <a:spLocks noGrp="1"/>
           </p:cNvSpPr>
@@ -2576,7 +2744,7 @@
         <p:spPr>
           <a:xfrm>
             <a:off x="686000" y="1500000"/>
-            <a:ext cx="10820000" cy="3400000"/>
+            <a:ext cx="5571280" cy="3900000"/>
           </a:xfrm>
           <a:prstGeom prst="rect">
             <a:avLst/>
@@ -2600,7 +2768,7 @@
               <a:buChar char="•"/>
             </a:pPr>
             <a:r>
-              <a:rPr lang="uz-UZ" sz="1800" b="1" i="0" dirty="0">
+              <a:rPr lang="uz-UZ" sz="1700" b="1" i="0" dirty="0">
                 <a:solidFill>
                   <a:srgbClr val="27E0C8"/>
                 </a:solidFill>
@@ -2610,7 +2778,7 @@
               <a:t>Yozish. </a:t>
             </a:r>
             <a:r>
-              <a:rPr lang="uz-UZ" sz="1600" b="0" i="0" dirty="0">
+              <a:rPr lang="uz-UZ" sz="1500" b="0" i="0" dirty="0">
                 <a:solidFill>
                   <a:srgbClr val="EAF2FF"/>
                 </a:solidFill>
@@ -2632,7 +2800,7 @@
               <a:buChar char="•"/>
             </a:pPr>
             <a:r>
-              <a:rPr lang="uz-UZ" sz="1800" b="1" i="0" dirty="0">
+              <a:rPr lang="uz-UZ" sz="1700" b="1" i="0" dirty="0">
                 <a:solidFill>
                   <a:srgbClr val="27E0C8"/>
                 </a:solidFill>
@@ -2642,7 +2810,7 @@
               <a:t>O'qish. </a:t>
             </a:r>
             <a:r>
-              <a:rPr lang="uz-UZ" sz="1600" b="0" i="0" dirty="0">
+              <a:rPr lang="uz-UZ" sz="1500" b="0" i="0" dirty="0">
                 <a:solidFill>
                   <a:srgbClr val="EAF2FF"/>
                 </a:solidFill>
@@ -2664,7 +2832,7 @@
               <a:buChar char="•"/>
             </a:pPr>
             <a:r>
-              <a:rPr lang="uz-UZ" sz="1800" b="1" i="0" dirty="0">
+              <a:rPr lang="uz-UZ" sz="1700" b="1" i="0" dirty="0">
                 <a:solidFill>
                   <a:srgbClr val="27E0C8"/>
                 </a:solidFill>
@@ -2674,7 +2842,7 @@
               <a:t>O'chirish. </a:t>
             </a:r>
             <a:r>
-              <a:rPr lang="uz-UZ" sz="1600" b="0" i="0" dirty="0">
+              <a:rPr lang="uz-UZ" sz="1500" b="0" i="0" dirty="0">
                 <a:solidFill>
                   <a:srgbClr val="EAF2FF"/>
                 </a:solidFill>
@@ -2696,7 +2864,7 @@
               <a:buChar char="•"/>
             </a:pPr>
             <a:r>
-              <a:rPr lang="uz-UZ" sz="1800" b="1" i="0" dirty="0">
+              <a:rPr lang="uz-UZ" sz="1700" b="1" i="0" dirty="0">
                 <a:solidFill>
                   <a:srgbClr val="27E0C8"/>
                 </a:solidFill>
@@ -2706,7 +2874,7 @@
               <a:t>Ikkilik sanoq sistemasi. </a:t>
             </a:r>
             <a:r>
-              <a:rPr lang="uz-UZ" sz="1600" b="0" i="0" dirty="0">
+              <a:rPr lang="uz-UZ" sz="1500" b="0" i="0" dirty="0">
                 <a:solidFill>
                   <a:srgbClr val="EAF2FF"/>
                 </a:solidFill>
@@ -2718,9 +2886,33 @@
           </a:p>
         </p:txBody>
       </p:sp>
-      <p:sp>
-        <p:nvSpPr>
-          <p:cNvPr id="5" name="url_caption"/>
+      <p:pic>
+        <p:nvPicPr>
+          <p:cNvPr id="5" name="diagram"/>
+          <p:cNvPicPr>
+            <a:picLocks noChangeAspect="1"/>
+          </p:cNvPicPr>
+          <p:nvPr/>
+        </p:nvPicPr>
+        <p:blipFill>
+          <a:blip r:embed="rId2"/>
+          <a:stretch>
+            <a:fillRect/>
+          </a:stretch>
+        </p:blipFill>
+        <p:spPr>
+          <a:xfrm>
+            <a:off x="6507280" y="1550000"/>
+            <a:ext cx="4998720" cy="3767328"/>
+          </a:xfrm>
+          <a:prstGeom prst="rect">
+            <a:avLst/>
+          </a:prstGeom>
+        </p:spPr>
+      </p:pic>
+      <p:sp>
+        <p:nvSpPr>
+          <p:cNvPr id="6" name="url_caption"/>
           <p:cNvSpPr>
             <a:spLocks noGrp="1"/>
           </p:cNvSpPr>
@@ -2925,7 +3117,7 @@
         <p:spPr>
           <a:xfrm>
             <a:off x="686000" y="1500000"/>
-            <a:ext cx="10820000" cy="3400000"/>
+            <a:ext cx="5571280" cy="3900000"/>
           </a:xfrm>
           <a:prstGeom prst="rect">
             <a:avLst/>
@@ -2949,7 +3141,7 @@
               <a:buChar char="•"/>
             </a:pPr>
             <a:r>
-              <a:rPr lang="uz-UZ" sz="1800" b="1" i="0" dirty="0">
+              <a:rPr lang="uz-UZ" sz="1700" b="1" i="0" dirty="0">
                 <a:solidFill>
                   <a:srgbClr val="27E0C8"/>
                 </a:solidFill>
@@ -2959,7 +3151,7 @@
               <a:t>Rasm — baytlar to'plami. </a:t>
             </a:r>
             <a:r>
-              <a:rPr lang="uz-UZ" sz="1600" b="0" i="0" dirty="0">
+              <a:rPr lang="uz-UZ" sz="1500" b="0" i="0" dirty="0">
                 <a:solidFill>
                   <a:srgbClr val="EAF2FF"/>
                 </a:solidFill>
@@ -2981,7 +3173,7 @@
               <a:buChar char="•"/>
             </a:pPr>
             <a:r>
-              <a:rPr lang="uz-UZ" sz="1800" b="1" i="0" dirty="0">
+              <a:rPr lang="uz-UZ" sz="1700" b="1" i="0" dirty="0">
                 <a:solidFill>
                   <a:srgbClr val="27E0C8"/>
                 </a:solidFill>
@@ -2991,7 +3183,7 @@
               <a:t>Baytlardan katakchalarga. </a:t>
             </a:r>
             <a:r>
-              <a:rPr lang="uz-UZ" sz="1600" b="0" i="0" dirty="0">
+              <a:rPr lang="uz-UZ" sz="1500" b="0" i="0" dirty="0">
                 <a:solidFill>
                   <a:srgbClr val="EAF2FF"/>
                 </a:solidFill>
@@ -3013,7 +3205,7 @@
               <a:buChar char="•"/>
             </a:pPr>
             <a:r>
-              <a:rPr lang="uz-UZ" sz="1800" b="1" i="0" dirty="0">
+              <a:rPr lang="uz-UZ" sz="1700" b="1" i="0" dirty="0">
                 <a:solidFill>
                   <a:srgbClr val="27E0C8"/>
                 </a:solidFill>
@@ -3023,7 +3215,7 @@
               <a:t>Katta sig'im. </a:t>
             </a:r>
             <a:r>
-              <a:rPr lang="uz-UZ" sz="1600" b="0" i="0" dirty="0">
+              <a:rPr lang="uz-UZ" sz="1500" b="0" i="0" dirty="0">
                 <a:solidFill>
                   <a:srgbClr val="EAF2FF"/>
                 </a:solidFill>
@@ -3045,7 +3237,7 @@
               <a:buChar char="•"/>
             </a:pPr>
             <a:r>
-              <a:rPr lang="uz-UZ" sz="1800" b="1" i="0" dirty="0">
+              <a:rPr lang="uz-UZ" sz="1700" b="1" i="0" dirty="0">
                 <a:solidFill>
                   <a:srgbClr val="27E0C8"/>
                 </a:solidFill>
@@ -3055,7 +3247,7 @@
               <a:t>Manzillash. </a:t>
             </a:r>
             <a:r>
-              <a:rPr lang="uz-UZ" sz="1600" b="0" i="0" dirty="0">
+              <a:rPr lang="uz-UZ" sz="1500" b="0" i="0" dirty="0">
                 <a:solidFill>
                   <a:srgbClr val="EAF2FF"/>
                 </a:solidFill>
@@ -3067,9 +3259,33 @@
           </a:p>
         </p:txBody>
       </p:sp>
-      <p:sp>
-        <p:nvSpPr>
-          <p:cNvPr id="5" name="url_caption"/>
+      <p:pic>
+        <p:nvPicPr>
+          <p:cNvPr id="5" name="diagram"/>
+          <p:cNvPicPr>
+            <a:picLocks noChangeAspect="1"/>
+          </p:cNvPicPr>
+          <p:nvPr/>
+        </p:nvPicPr>
+        <p:blipFill>
+          <a:blip r:embed="rId2"/>
+          <a:stretch>
+            <a:fillRect/>
+          </a:stretch>
+        </p:blipFill>
+        <p:spPr>
+          <a:xfrm>
+            <a:off x="6507280" y="1550000"/>
+            <a:ext cx="4998720" cy="3767328"/>
+          </a:xfrm>
+          <a:prstGeom prst="rect">
+            <a:avLst/>
+          </a:prstGeom>
+        </p:spPr>
+      </p:pic>
+      <p:sp>
+        <p:nvSpPr>
+          <p:cNvPr id="6" name="url_caption"/>
           <p:cNvSpPr>
             <a:spLocks noGrp="1"/>
           </p:cNvSpPr>
@@ -3274,7 +3490,7 @@
         <p:spPr>
           <a:xfrm>
             <a:off x="686000" y="1500000"/>
-            <a:ext cx="10820000" cy="3400000"/>
+            <a:ext cx="5571280" cy="3900000"/>
           </a:xfrm>
           <a:prstGeom prst="rect">
             <a:avLst/>
@@ -3298,7 +3514,7 @@
               <a:buChar char="•"/>
             </a:pPr>
             <a:r>
-              <a:rPr lang="uz-UZ" sz="1800" b="1" i="0" dirty="0">
+              <a:rPr lang="uz-UZ" sz="1700" b="1" i="0" dirty="0">
                 <a:solidFill>
                   <a:srgbClr val="5AA9FF"/>
                 </a:solidFill>
@@ -3308,7 +3524,7 @@
               <a:t>Afzalliklari. </a:t>
             </a:r>
             <a:r>
-              <a:rPr lang="uz-UZ" sz="1600" b="0" i="0" dirty="0">
+              <a:rPr lang="uz-UZ" sz="1500" b="0" i="0" dirty="0">
                 <a:solidFill>
                   <a:srgbClr val="EAF2FF"/>
                 </a:solidFill>
@@ -3330,7 +3546,7 @@
               <a:buChar char="•"/>
             </a:pPr>
             <a:r>
-              <a:rPr lang="uz-UZ" sz="1800" b="1" i="0" dirty="0">
+              <a:rPr lang="uz-UZ" sz="1700" b="1" i="0" dirty="0">
                 <a:solidFill>
                   <a:srgbClr val="5AA9FF"/>
                 </a:solidFill>
@@ -3340,7 +3556,7 @@
               <a:t>Chidamliligi. </a:t>
             </a:r>
             <a:r>
-              <a:rPr lang="uz-UZ" sz="1600" b="0" i="0" dirty="0">
+              <a:rPr lang="uz-UZ" sz="1500" b="0" i="0" dirty="0">
                 <a:solidFill>
                   <a:srgbClr val="EAF2FF"/>
                 </a:solidFill>
@@ -3362,7 +3578,7 @@
               <a:buChar char="•"/>
             </a:pPr>
             <a:r>
-              <a:rPr lang="uz-UZ" sz="1800" b="1" i="0" dirty="0">
+              <a:rPr lang="uz-UZ" sz="1700" b="1" i="0" dirty="0">
                 <a:solidFill>
                   <a:srgbClr val="5AA9FF"/>
                 </a:solidFill>
@@ -3372,14 +3588,14 @@
               <a:t>Texnologiya kelajagi. </a:t>
             </a:r>
             <a:r>
-              <a:rPr lang="uz-UZ" sz="1600" b="0" i="0" dirty="0">
-                <a:solidFill>
-                  <a:srgbClr val="EAF2FF"/>
-                </a:solidFill>
-                <a:latin typeface="Times New Roman"/>
-                <a:cs typeface="Times New Roman"/>
-              </a:rPr>
-              <a:t>3D NAND va yangi yarimo'tkazgich materiallari sig'imni oshirib, narxni pasaytirmoqda — kelajakda yanada tezroq va hajmli xotira kutilmoqda.</a:t>
+              <a:rPr lang="uz-UZ" sz="1500" b="0" i="0" dirty="0">
+                <a:solidFill>
+                  <a:srgbClr val="EAF2FF"/>
+                </a:solidFill>
+                <a:latin typeface="Times New Roman"/>
+                <a:cs typeface="Times New Roman"/>
+              </a:rPr>
+              <a:t>3D NAND va yangi yarimo'tkazgich materiallari sig'imni oshirib, narxni pasaytirmoqda — kelajakda yanada tezroq xotira kutilmoqda.</a:t>
             </a:r>
           </a:p>
           <a:p>
@@ -3394,7 +3610,7 @@
               <a:buChar char="•"/>
             </a:pPr>
             <a:r>
-              <a:rPr lang="uz-UZ" sz="1800" b="1" i="0" dirty="0">
+              <a:rPr lang="uz-UZ" sz="1700" b="1" i="0" dirty="0">
                 <a:solidFill>
                   <a:srgbClr val="5AA9FF"/>
                 </a:solidFill>
@@ -3404,7 +3620,7 @@
               <a:t>Umumiy xulosa. </a:t>
             </a:r>
             <a:r>
-              <a:rPr lang="uz-UZ" sz="1600" b="0" i="0" dirty="0">
+              <a:rPr lang="uz-UZ" sz="1500" b="0" i="0" dirty="0">
                 <a:solidFill>
                   <a:srgbClr val="EAF2FF"/>
                 </a:solidFill>
@@ -3416,9 +3632,33 @@
           </a:p>
         </p:txBody>
       </p:sp>
-      <p:sp>
-        <p:nvSpPr>
-          <p:cNvPr id="5" name="url_caption"/>
+      <p:pic>
+        <p:nvPicPr>
+          <p:cNvPr id="5" name="diagram"/>
+          <p:cNvPicPr>
+            <a:picLocks noChangeAspect="1"/>
+          </p:cNvPicPr>
+          <p:nvPr/>
+        </p:nvPicPr>
+        <p:blipFill>
+          <a:blip r:embed="rId2"/>
+          <a:stretch>
+            <a:fillRect/>
+          </a:stretch>
+        </p:blipFill>
+        <p:spPr>
+          <a:xfrm>
+            <a:off x="6507280" y="1550000"/>
+            <a:ext cx="4998720" cy="3767328"/>
+          </a:xfrm>
+          <a:prstGeom prst="rect">
+            <a:avLst/>
+          </a:prstGeom>
+        </p:spPr>
+      </p:pic>
+      <p:sp>
+        <p:nvSpPr>
+          <p:cNvPr id="6" name="url_caption"/>
           <p:cNvSpPr>
             <a:spLocks noGrp="1"/>
           </p:cNvSpPr>

</xml_diff>